<commit_message>
Clarify AI content production line entry
</commit_message>
<xml_diff>
--- a/docs/bp/2026-08-09-vulca-enterprise-ai-production-line/VULCA-企业视觉智能公司-BP-v3.pptx
+++ b/docs/bp/2026-08-09-vulca-enterprise-ai-production-line/VULCA-企业视觉智能公司-BP-v3.pptx
@@ -2,18 +2,18 @@
 <file path=ppt/presentation.xml><?xml version="1.0" encoding="utf-8"?>
 <p:presentation xmlns:p="http://schemas.openxmlformats.org/presentationml/2006/main">
   <p:sldMasterIdLst>
-    <p:sldMasterId xmlns:r="http://schemas.openxmlformats.org/officeDocument/2006/relationships" id="2147483648" r:id="R15929010b7194293"/>
+    <p:sldMasterId xmlns:r="http://schemas.openxmlformats.org/officeDocument/2006/relationships" id="2147483648" r:id="R8bfc65e86ba543d5"/>
   </p:sldMasterIdLst>
   <p:notesMasterIdLst>
-    <p:notesMasterId xmlns:r="http://schemas.openxmlformats.org/officeDocument/2006/relationships" r:id="R0b53db26cc244101"/>
+    <p:notesMasterId xmlns:r="http://schemas.openxmlformats.org/officeDocument/2006/relationships" r:id="Ra7f70bdb9e34485e"/>
   </p:notesMasterIdLst>
   <p:sldIdLst>
-    <p:sldId xmlns:r="http://schemas.openxmlformats.org/officeDocument/2006/relationships" id="256" r:id="R8253553fb8f3437b"/>
-    <p:sldId xmlns:r="http://schemas.openxmlformats.org/officeDocument/2006/relationships" id="257" r:id="R7667b7049e224d34"/>
-    <p:sldId xmlns:r="http://schemas.openxmlformats.org/officeDocument/2006/relationships" id="258" r:id="Rf8c2701366514403"/>
-    <p:sldId xmlns:r="http://schemas.openxmlformats.org/officeDocument/2006/relationships" id="259" r:id="Rb65d01277b2f4d42"/>
-    <p:sldId xmlns:r="http://schemas.openxmlformats.org/officeDocument/2006/relationships" id="260" r:id="Ra03f0285a32a4775"/>
-    <p:sldId xmlns:r="http://schemas.openxmlformats.org/officeDocument/2006/relationships" id="261" r:id="R14b3e891cea64b56"/>
+    <p:sldId xmlns:r="http://schemas.openxmlformats.org/officeDocument/2006/relationships" id="256" r:id="R100c62cce5f74a14"/>
+    <p:sldId xmlns:r="http://schemas.openxmlformats.org/officeDocument/2006/relationships" id="257" r:id="R973ac18f2b1749ef"/>
+    <p:sldId xmlns:r="http://schemas.openxmlformats.org/officeDocument/2006/relationships" id="258" r:id="Rcda5969b58a04cdb"/>
+    <p:sldId xmlns:r="http://schemas.openxmlformats.org/officeDocument/2006/relationships" id="259" r:id="R52a874fc7f3643d8"/>
+    <p:sldId xmlns:r="http://schemas.openxmlformats.org/officeDocument/2006/relationships" id="260" r:id="Ra8706ec26dd5490e"/>
+    <p:sldId xmlns:r="http://schemas.openxmlformats.org/officeDocument/2006/relationships" id="261" r:id="R197655812a0f4aaf"/>
   </p:sldIdLst>
   <p:sldSz cx="12192000" cy="6858000"/>
   <p:notesSz cx="6858000" cy="9144000"/>
@@ -447,7 +447,7 @@
           <a:lstStyle xmlns:a="http://schemas.openxmlformats.org/drawingml/2006/main"/>
           <a:p xmlns:a="http://schemas.openxmlformats.org/drawingml/2006/main">
             <a:r>
-              <a:t>VULCA 的公司主语不是某一种模型，也不是一次性交付。我们是一家企业视觉智能公司。当前产品是一套企业 AI 视觉生产系统，客户得到的不是一个工具清单，而是一支会创作、懂品牌、能协作，并能在企业授权下持续成长的 AI 视觉团队。</a:t>
+              <a:t>VULCA 的公司主语不是某一种模型，也不是一次性交付。我们是一家企业视觉智能公司。当前产品和市场入口是一条企业 AI 内容生产线；它背后是一套企业视觉生产系统。客户得到的不是工具清单，而是一支会创作、懂品牌、能协作，并能在企业授权下持续成长的 AI 视觉团队。</a:t>
             </a:r>
           </a:p>
           <a:p xmlns:a="http://schemas.openxmlformats.org/drawingml/2006/main">
@@ -617,7 +617,7 @@
           <a:lstStyle xmlns:a="http://schemas.openxmlformats.org/drawingml/2006/main"/>
           <a:p xmlns:a="http://schemas.openxmlformats.org/drawingml/2006/main">
             <a:r>
-              <a:t>这页回答 VULCA 到底卖什么，以及上下游分别是谁。上游是闭源和开源模型、算力与创作工具；首个入口是同时服务多个品牌的 AI 创意、本地化和跨境营销服务商；下游是品牌团队、区域市场和最终采用者。VULCA 把这些能力接成一套每天可运行、可评测、可迁移的企业 AI 视觉生产系统。企业保留目标、最终采用与用途授权。</a:t>
+              <a:t>这页回答 VULCA 到底卖什么，以及上下游分别是谁。上游是闭源和开源模型、算力与创作工具；首个入口是同时服务多个品牌的 AI 创意、本地化和跨境营销服务商；下游是品牌团队、区域市场和最终采用者。VULCA 通过企业 AI 内容生产线，把这些能力接成每天可运行、可评测、可迁移的视觉生产系统。企业保留目标、最终采用与用途授权。</a:t>
             </a:r>
           </a:p>
           <a:p xmlns:a="http://schemas.openxmlformats.org/drawingml/2006/main">
@@ -975,7 +975,7 @@
   </p:cSld>
   <p:clrMap bg1="lt1" tx1="dk1" bg2="lt2" tx2="dk2" accent1="accent1" accent2="accent2" accent3="accent3" accent4="accent4" accent5="accent5" accent6="accent6" hlink="hlink" folHlink="folHlink"/>
   <p:sldLayoutIdLst>
-    <p:sldLayoutId xmlns:r="http://schemas.openxmlformats.org/officeDocument/2006/relationships" id="2147483649" r:id="R19313278a67649a0"/>
+    <p:sldLayoutId xmlns:r="http://schemas.openxmlformats.org/officeDocument/2006/relationships" id="2147483649" r:id="R3a64f543e15d4c3c"/>
   </p:sldLayoutIdLst>
   <p:txStyles>
     <p:titleStyle>
@@ -1884,7 +1884,7 @@
                 <a:ea typeface="PingFang SC"/>
                 <a:cs typeface="PingFang SC"/>
               </a:rPr>
-              <a:t>企业 AI 视觉生产系统</a:t>
+              <a:t>企业 AI 内容生产线</a:t>
             </a:r>
           </a:p>
           <a:p xmlns:a="http://schemas.openxmlformats.org/drawingml/2006/main">
@@ -4194,7 +4194,7 @@
                 <a:ea typeface="PingFang SC"/>
                 <a:cs typeface="PingFang SC"/>
               </a:rPr>
-              <a:t>连接成一套可以持续进化的视觉系统。</a:t>
+              <a:t>连接成一条可以持续进化的内容生产线。</a:t>
             </a:r>
           </a:p>
         </p:txBody>
@@ -4804,7 +4804,7 @@
                 <a:ea typeface="PingFang SC"/>
                 <a:cs typeface="PingFang SC"/>
               </a:rPr>
-              <a:t>AI 视觉生产系统</a:t>
+              <a:t>企业 AI 内容生产线</a:t>
             </a:r>
           </a:p>
         </p:txBody>
@@ -6028,7 +6028,7 @@
       </p:sp>
       <p:cxnSp>
         <p:nvCxnSpPr>
-          <p:cNvPr id="27" name="Google-Shape-2259-p159-4"/>
+          <p:cNvPr id="30" name="Google-Shape-2259-p159-4"/>
           <p:cNvCxnSpPr/>
           <p:nvPr/>
         </p:nvCxnSpPr>
@@ -6906,7 +6906,7 @@
       </p:sp>
       <p:cxnSp>
         <p:nvCxnSpPr>
-          <p:cNvPr id="27" name="Google-Shape-2259-p159-4"/>
+          <p:cNvPr id="30" name="Google-Shape-2259-p159-4"/>
           <p:cNvCxnSpPr/>
           <p:nvPr/>
         </p:nvCxnSpPr>

</xml_diff>